<commit_message>
Revise project overview docs
</commit_message>
<xml_diff>
--- a/docs/PureGym-Support-Hub-Presentation.pptx
+++ b/docs/PureGym-Support-Hub-Presentation.pptx
@@ -522,7 +522,7 @@
                 </a:solidFill>
                 <a:latin typeface="Arial"/>
               </a:rPr>
-              <a:t>The hub removes daily support friction</a:t>
+              <a:t>Agents get one focused workspace</a:t>
             </a:r>
             <a:endParaRPr lang="en-US" sz="3500"/>
           </a:p>
@@ -559,7 +559,7 @@
                 </a:solidFill>
                 <a:latin typeface="Arial"/>
               </a:rPr>
-              <a:t>Agents should not jump between scattered notes, admin changes, and AI tools during a live conversation.</a:t>
+              <a:t>The dashboard keeps daily support work inside one organized screen.</a:t>
             </a:r>
             <a:endParaRPr lang="en-US" sz="1700"/>
           </a:p>
@@ -635,7 +635,7 @@
                 </a:solidFill>
                 <a:latin typeface="Arial"/>
               </a:rPr>
-              <a:t>- Admin changes live in Neon, not old project files.</a:t>
+              <a:t>- Admin changes are stored in Neon, not old project files.</a:t>
             </a:r>
             <a:endParaRPr lang="en-US" sz="1700"/>
           </a:p>
@@ -1047,7 +1047,7 @@
                 </a:solidFill>
                 <a:latin typeface="Arial"/>
               </a:rPr>
-              <a:t>Neon-backed live content</a:t>
+              <a:t>Neon-backed content</a:t>
             </a:r>
             <a:endParaRPr lang="en-US" sz="1100"/>
           </a:p>
@@ -1208,7 +1208,7 @@
                 </a:solidFill>
                 <a:latin typeface="Arial"/>
               </a:rPr>
-              <a:t>The latest batch makes scripts faster to reach</a:t>
+              <a:t>Script Library and Quick Scripts stay controlled</a:t>
             </a:r>
             <a:endParaRPr lang="en-US" sz="3500"/>
           </a:p>
@@ -1245,7 +1245,7 @@
                 </a:solidFill>
                 <a:latin typeface="Arial"/>
               </a:rPr>
-              <a:t>Ctrl+K and variable prompts turn the script library into a keyboard-first tool.</a:t>
+              <a:t>Shared content is easier to manage and safer to use.</a:t>
             </a:r>
             <a:endParaRPr lang="en-US" sz="1700"/>
           </a:p>
@@ -1282,7 +1282,7 @@
                 </a:solidFill>
                 <a:latin typeface="Arial"/>
               </a:rPr>
-              <a:t>- Ctrl+K opens the in-app command palette when the page has focus.</a:t>
+              <a:t>- Script Library supports category filtering, favorites, activation, and one-click copy.</a:t>
             </a:r>
             <a:endParaRPr lang="en-US" sz="1700"/>
           </a:p>
@@ -1295,7 +1295,7 @@
                 </a:solidFill>
                 <a:latin typeface="Arial"/>
               </a:rPr>
-              <a:t>- Copying a script can prompt for date, duration, amount, membership type, or member name.</a:t>
+              <a:t>- Quick Scripts are shared from the master Script table so admin edits apply to everyone.</a:t>
             </a:r>
             <a:endParaRPr lang="en-US" sz="1700"/>
           </a:p>
@@ -1308,7 +1308,7 @@
                 </a:solidFill>
                 <a:latin typeface="Arial"/>
               </a:rPr>
-              <a:t>- The same copy pipeline applies name, gender, country heart, variables, and usage tracking.</a:t>
+              <a:t>- Admins can drag cards to reorder Quick Scripts instead of clicking arrows repeatedly.</a:t>
             </a:r>
             <a:endParaRPr lang="en-US" sz="1700"/>
           </a:p>
@@ -1321,7 +1321,7 @@
                 </a:solidFill>
                 <a:latin typeface="Arial"/>
               </a:rPr>
-              <a:t>- Most-used scripts are tracked per agent locally.</a:t>
+              <a:t>- Male/Female wording toggles work from regular and favorite Quick Script cards.</a:t>
             </a:r>
             <a:endParaRPr lang="en-US" sz="1700"/>
           </a:p>
@@ -1490,7 +1490,7 @@
                 </a:solidFill>
                 <a:latin typeface="Arial"/>
               </a:rPr>
-              <a:t>Shortcut</a:t>
+              <a:t>Library</a:t>
             </a:r>
             <a:endParaRPr lang="en-US" sz="1300"/>
           </a:p>
@@ -1527,7 +1527,7 @@
                 </a:solidFill>
                 <a:latin typeface="Arial"/>
               </a:rPr>
-              <a:t>Ctrl+K command palette</a:t>
+              <a:t>Search and copy</a:t>
             </a:r>
             <a:endParaRPr lang="en-US" sz="1100"/>
           </a:p>
@@ -1593,7 +1593,7 @@
                 </a:solidFill>
                 <a:latin typeface="Arial"/>
               </a:rPr>
-              <a:t>Fill</a:t>
+              <a:t>Quick</a:t>
             </a:r>
             <a:endParaRPr lang="en-US" sz="1300"/>
           </a:p>
@@ -1630,7 +1630,7 @@
                 </a:solidFill>
                 <a:latin typeface="Arial"/>
               </a:rPr>
-              <a:t>Dates and script variables</a:t>
+              <a:t>Shared and ordered</a:t>
             </a:r>
             <a:endParaRPr lang="en-US" sz="1100"/>
           </a:p>
@@ -1696,7 +1696,7 @@
                 </a:solidFill>
                 <a:latin typeface="Arial"/>
               </a:rPr>
-              <a:t>Copy</a:t>
+              <a:t>Favorite</a:t>
             </a:r>
             <a:endParaRPr lang="en-US" sz="1300"/>
           </a:p>
@@ -1733,7 +1733,7 @@
                 </a:solidFill>
                 <a:latin typeface="Arial"/>
               </a:rPr>
-              <a:t>Ready-to-send output</a:t>
+              <a:t>Personal per user</a:t>
             </a:r>
             <a:endParaRPr lang="en-US" sz="1100"/>
           </a:p>
@@ -1894,7 +1894,7 @@
                 </a:solidFill>
                 <a:latin typeface="Arial"/>
               </a:rPr>
-              <a:t>AI now runs on a low-cost provider by default</a:t>
+              <a:t>Search and copy flows are built for speed</a:t>
             </a:r>
             <a:endParaRPr lang="en-US" sz="3500"/>
           </a:p>
@@ -1931,7 +1931,7 @@
                 </a:solidFill>
                 <a:latin typeface="Arial"/>
               </a:rPr>
-              <a:t>The app is no longer locked to OpenAI billing.</a:t>
+              <a:t>Agents can reach the right wording without moving through long lists.</a:t>
             </a:r>
             <a:endParaRPr lang="en-US" sz="1700"/>
           </a:p>
@@ -1968,7 +1968,7 @@
                 </a:solidFill>
                 <a:latin typeface="Arial"/>
               </a:rPr>
-              <a:t>- Groq is the default provider using llama-3.1-8b-instant.</a:t>
+              <a:t>- Ctrl+K opens the in-app command palette when the page has focus.</a:t>
             </a:r>
             <a:endParaRPr lang="en-US" sz="1700"/>
           </a:p>
@@ -1981,7 +1981,7 @@
                 </a:solidFill>
                 <a:latin typeface="Arial"/>
               </a:rPr>
-              <a:t>- Gemini can be enabled with GEMINI_API_KEY and AI_PROVIDER=gemini.</a:t>
+              <a:t>- Most-used scripts are tracked per agent locally.</a:t>
             </a:r>
             <a:endParaRPr lang="en-US" sz="1700"/>
           </a:p>
@@ -1994,7 +1994,7 @@
                 </a:solidFill>
                 <a:latin typeface="Arial"/>
               </a:rPr>
-              <a:t>- OpenAI stays available only as an intentional fallback.</a:t>
+              <a:t>- Copying a script can prompt for date, duration, amount, membership type, or member name.</a:t>
             </a:r>
             <a:endParaRPr lang="en-US" sz="1700"/>
           </a:p>
@@ -2007,7 +2007,7 @@
                 </a:solidFill>
                 <a:latin typeface="Arial"/>
               </a:rPr>
-              <a:t>- The AI health route now reports provider, model, database status, and configuration readiness.</a:t>
+              <a:t>- The copy pipeline applies employee name, gender, country heart, variables, and usage tracking.</a:t>
             </a:r>
             <a:endParaRPr lang="en-US" sz="1700"/>
           </a:p>
@@ -2176,7 +2176,7 @@
                 </a:solidFill>
                 <a:latin typeface="Arial"/>
               </a:rPr>
-              <a:t>Default</a:t>
+              <a:t>Shortcut</a:t>
             </a:r>
             <a:endParaRPr lang="en-US" sz="1300"/>
           </a:p>
@@ -2213,7 +2213,7 @@
                 </a:solidFill>
                 <a:latin typeface="Arial"/>
               </a:rPr>
-              <a:t>Groq</a:t>
+              <a:t>Ctrl+K</a:t>
             </a:r>
             <a:endParaRPr lang="en-US" sz="1100"/>
           </a:p>
@@ -2279,7 +2279,7 @@
                 </a:solidFill>
                 <a:latin typeface="Arial"/>
               </a:rPr>
-              <a:t>Alternative</a:t>
+              <a:t>Fill</a:t>
             </a:r>
             <a:endParaRPr lang="en-US" sz="1300"/>
           </a:p>
@@ -2316,7 +2316,7 @@
                 </a:solidFill>
                 <a:latin typeface="Arial"/>
               </a:rPr>
-              <a:t>Gemini</a:t>
+              <a:t>Smart prompts</a:t>
             </a:r>
             <a:endParaRPr lang="en-US" sz="1100"/>
           </a:p>
@@ -2382,7 +2382,7 @@
                 </a:solidFill>
                 <a:latin typeface="Arial"/>
               </a:rPr>
-              <a:t>Fallback</a:t>
+              <a:t>Copy</a:t>
             </a:r>
             <a:endParaRPr lang="en-US" sz="1300"/>
           </a:p>
@@ -2419,7 +2419,7 @@
                 </a:solidFill>
                 <a:latin typeface="Arial"/>
               </a:rPr>
-              <a:t>OpenAI only if selected</a:t>
+              <a:t>Ready output</a:t>
             </a:r>
             <a:endParaRPr lang="en-US" sz="1100"/>
           </a:p>
@@ -2580,7 +2580,7 @@
                 </a:solidFill>
                 <a:latin typeface="Arial"/>
               </a:rPr>
-              <a:t>Admin governance protects shared content</a:t>
+              <a:t>AI helps agents answer with context</a:t>
             </a:r>
             <a:endParaRPr lang="en-US" sz="3500"/>
           </a:p>
@@ -2617,7 +2617,7 @@
                 </a:solidFill>
                 <a:latin typeface="Arial"/>
               </a:rPr>
-              <a:t>The model separates daily usage from global content control.</a:t>
+              <a:t>The assistant uses the hub's own knowledge instead of generic answers.</a:t>
             </a:r>
             <a:endParaRPr lang="en-US" sz="1700"/>
           </a:p>
@@ -2654,7 +2654,7 @@
                 </a:solidFill>
                 <a:latin typeface="Arial"/>
               </a:rPr>
-              <a:t>- Super Admin owns role changes and user removal.</a:t>
+              <a:t>- Groq is the default provider using llama-3.1-8b-instant.</a:t>
             </a:r>
             <a:endParaRPr lang="en-US" sz="1700"/>
           </a:p>
@@ -2667,7 +2667,7 @@
                 </a:solidFill>
                 <a:latin typeface="Arial"/>
               </a:rPr>
-              <a:t>- Admin and Super Admin can manage scripts and quick scripts.</a:t>
+              <a:t>- Gemini and OpenAI remain optional providers through environment variables.</a:t>
             </a:r>
             <a:endParaRPr lang="en-US" sz="1700"/>
           </a:p>
@@ -2680,7 +2680,7 @@
                 </a:solidFill>
                 <a:latin typeface="Arial"/>
               </a:rPr>
-              <a:t>- Deactivation hides scripts or categories globally without deleting the record.</a:t>
+              <a:t>- AI Trainer accepts text, links, and image references as reusable knowledge.</a:t>
             </a:r>
             <a:endParaRPr lang="en-US" sz="1700"/>
           </a:p>
@@ -2693,7 +2693,7 @@
                 </a:solidFill>
                 <a:latin typeface="Arial"/>
               </a:rPr>
-              <a:t>- Account requests can be approved with generated passwords.</a:t>
+              <a:t>- The chatbot uses scripts, official knowledge, memory, and country/language signals.</a:t>
             </a:r>
             <a:endParaRPr lang="en-US" sz="1700"/>
           </a:p>
@@ -2862,7 +2862,7 @@
                 </a:solidFill>
                 <a:latin typeface="Arial"/>
               </a:rPr>
-              <a:t>Super Admin</a:t>
+              <a:t>Chatbot</a:t>
             </a:r>
             <a:endParaRPr lang="en-US" sz="1300"/>
           </a:p>
@@ -2899,7 +2899,7 @@
                 </a:solidFill>
                 <a:latin typeface="Arial"/>
               </a:rPr>
-              <a:t>User authority</a:t>
+              <a:t>Support context</a:t>
             </a:r>
             <a:endParaRPr lang="en-US" sz="1100"/>
           </a:p>
@@ -2965,7 +2965,7 @@
                 </a:solidFill>
                 <a:latin typeface="Arial"/>
               </a:rPr>
-              <a:t>Admin</a:t>
+              <a:t>Trainer</a:t>
             </a:r>
             <a:endParaRPr lang="en-US" sz="1300"/>
           </a:p>
@@ -3002,7 +3002,7 @@
                 </a:solidFill>
                 <a:latin typeface="Arial"/>
               </a:rPr>
-              <a:t>Content authority</a:t>
+              <a:t>Reusable knowledge</a:t>
             </a:r>
             <a:endParaRPr lang="en-US" sz="1100"/>
           </a:p>
@@ -3068,7 +3068,7 @@
                 </a:solidFill>
                 <a:latin typeface="Arial"/>
               </a:rPr>
-              <a:t>User</a:t>
+              <a:t>Spellcheck</a:t>
             </a:r>
             <a:endParaRPr lang="en-US" sz="1300"/>
           </a:p>
@@ -3105,7 +3105,7 @@
                 </a:solidFill>
                 <a:latin typeface="Arial"/>
               </a:rPr>
-              <a:t>Daily operation</a:t>
+              <a:t>Agent-controlled</a:t>
             </a:r>
             <a:endParaRPr lang="en-US" sz="1100"/>
           </a:p>
@@ -3266,7 +3266,7 @@
                 </a:solidFill>
                 <a:latin typeface="Arial"/>
               </a:rPr>
-              <a:t>QA now has a repeatable smoke path</a:t>
+              <a:t>Admin controls keep shared data clean</a:t>
             </a:r>
             <a:endParaRPr lang="en-US" sz="3500"/>
           </a:p>
@@ -3303,7 +3303,7 @@
                 </a:solidFill>
                 <a:latin typeface="Arial"/>
               </a:rPr>
-              <a:t>The project has a simple command for catching broken routes before deployment.</a:t>
+              <a:t>Role boundaries make it clear who can change operational content.</a:t>
             </a:r>
             <a:endParaRPr lang="en-US" sz="1700"/>
           </a:p>
@@ -3340,7 +3340,7 @@
                 </a:solidFill>
                 <a:latin typeface="Arial"/>
               </a:rPr>
-              <a:t>- npm run build verifies Prisma, Next.js, type checking, and static generation.</a:t>
+              <a:t>- Admin can manage scripts, categories, Quick Scripts, activation status, and shared support content.</a:t>
             </a:r>
             <a:endParaRPr lang="en-US" sz="1700"/>
           </a:p>
@@ -3353,7 +3353,7 @@
                 </a:solidFill>
                 <a:latin typeface="Arial"/>
               </a:rPr>
-              <a:t>- npm run smoke verifies page rendering and anonymous API protection.</a:t>
+              <a:t>- User creation, removal, and role changes are left to the development team.</a:t>
             </a:r>
             <a:endParaRPr lang="en-US" sz="1700"/>
           </a:p>
@@ -3366,7 +3366,7 @@
                 </a:solidFill>
                 <a:latin typeface="Arial"/>
               </a:rPr>
-              <a:t>- Authenticated smoke can run with SMOKE_EMAIL and SMOKE_PASSWORD.</a:t>
+              <a:t>- Deactivation hides scripts or categories globally without deleting the record.</a:t>
             </a:r>
             <a:endParaRPr lang="en-US" sz="1700"/>
           </a:p>
@@ -3379,7 +3379,7 @@
                 </a:solidFill>
                 <a:latin typeface="Arial"/>
               </a:rPr>
-              <a:t>- Quick-script authenticated checks are gated to avoid unintended database writes.</a:t>
+              <a:t>- Shared content changes apply to all users after saving.</a:t>
             </a:r>
             <a:endParaRPr lang="en-US" sz="1700"/>
           </a:p>
@@ -3548,7 +3548,7 @@
                 </a:solidFill>
                 <a:latin typeface="Arial"/>
               </a:rPr>
-              <a:t>Build</a:t>
+              <a:t>Admin</a:t>
             </a:r>
             <a:endParaRPr lang="en-US" sz="1300"/>
           </a:p>
@@ -3585,7 +3585,7 @@
                 </a:solidFill>
                 <a:latin typeface="Arial"/>
               </a:rPr>
-              <a:t>Production compile</a:t>
+              <a:t>Content authority</a:t>
             </a:r>
             <a:endParaRPr lang="en-US" sz="1100"/>
           </a:p>
@@ -3651,7 +3651,7 @@
                 </a:solidFill>
                 <a:latin typeface="Arial"/>
               </a:rPr>
-              <a:t>Smoke</a:t>
+              <a:t>Developers</a:t>
             </a:r>
             <a:endParaRPr lang="en-US" sz="1300"/>
           </a:p>
@@ -3688,7 +3688,7 @@
                 </a:solidFill>
                 <a:latin typeface="Arial"/>
               </a:rPr>
-              <a:t>Route protection</a:t>
+              <a:t>User accounts</a:t>
             </a:r>
             <a:endParaRPr lang="en-US" sz="1100"/>
           </a:p>
@@ -3754,7 +3754,7 @@
                 </a:solidFill>
                 <a:latin typeface="Arial"/>
               </a:rPr>
-              <a:t>Safe</a:t>
+              <a:t>User</a:t>
             </a:r>
             <a:endParaRPr lang="en-US" sz="1300"/>
           </a:p>
@@ -3791,7 +3791,7 @@
                 </a:solidFill>
                 <a:latin typeface="Arial"/>
               </a:rPr>
-              <a:t>No DB writes by default</a:t>
+              <a:t>Daily operation</a:t>
             </a:r>
             <a:endParaRPr lang="en-US" sz="1100"/>
           </a:p>
@@ -3952,7 +3952,7 @@
                 </a:solidFill>
                 <a:latin typeface="Arial"/>
               </a:rPr>
-              <a:t>The cost profile stays small for 25 users</a:t>
+              <a:t>Support tools cover common daily tasks</a:t>
             </a:r>
             <a:endParaRPr lang="en-US" sz="3500"/>
           </a:p>
@@ -3989,7 +3989,7 @@
                 </a:solidFill>
                 <a:latin typeface="Arial"/>
               </a:rPr>
-              <a:t>Support agents are app users, not infrastructure seats.</a:t>
+              <a:t>The hub includes utilities agents need during real support work.</a:t>
             </a:r>
             <a:endParaRPr lang="en-US" sz="1700"/>
           </a:p>
@@ -4026,7 +4026,7 @@
                 </a:solidFill>
                 <a:latin typeface="Arial"/>
               </a:rPr>
-              <a:t>- Vercel Hobby can run light use; Pro is safer for production ownership.</a:t>
+              <a:t>- Branch Directory gives searchable KSA and UAE branch references.</a:t>
             </a:r>
             <a:endParaRPr lang="en-US" sz="1700"/>
           </a:p>
@@ -4039,7 +4039,7 @@
                 </a:solidFill>
                 <a:latin typeface="Arial"/>
               </a:rPr>
-              <a:t>- Neon Free may be enough for small data; Launch is the practical growth step.</a:t>
+              <a:t>- Calculation Tool supports membership-related calculations.</a:t>
             </a:r>
             <a:endParaRPr lang="en-US" sz="1700"/>
           </a:p>
@@ -4052,7 +4052,7 @@
                 </a:solidFill>
                 <a:latin typeface="Arial"/>
               </a:rPr>
-              <a:t>- Groq token pricing keeps moderate AI usage in a low monthly range.</a:t>
+              <a:t>- Hijri Month supports Hijri to Gregorian and Gregorian to Hijri conversion.</a:t>
             </a:r>
             <a:endParaRPr lang="en-US" sz="1700"/>
           </a:p>
@@ -4065,7 +4065,7 @@
                 </a:solidFill>
                 <a:latin typeface="Arial"/>
               </a:rPr>
-              <a:t>- Gemini API free usage is another option when rate limits fit the workflow.</a:t>
+              <a:t>- Profile settings keep agent names available for script personalization.</a:t>
             </a:r>
             <a:endParaRPr lang="en-US" sz="1700"/>
           </a:p>
@@ -4234,7 +4234,7 @@
                 </a:solidFill>
                 <a:latin typeface="Arial"/>
               </a:rPr>
-              <a:t>Light use</a:t>
+              <a:t>Branches</a:t>
             </a:r>
             <a:endParaRPr lang="en-US" sz="1300"/>
           </a:p>
@@ -4271,7 +4271,7 @@
                 </a:solidFill>
                 <a:latin typeface="Arial"/>
               </a:rPr>
-              <a:t>$0-$10/mo</a:t>
+              <a:t>Searchable</a:t>
             </a:r>
             <a:endParaRPr lang="en-US" sz="1100"/>
           </a:p>
@@ -4337,7 +4337,7 @@
                 </a:solidFill>
                 <a:latin typeface="Arial"/>
               </a:rPr>
-              <a:t>Safer setup</a:t>
+              <a:t>Calendar</a:t>
             </a:r>
             <a:endParaRPr lang="en-US" sz="1300"/>
           </a:p>
@@ -4374,7 +4374,7 @@
                 </a:solidFill>
                 <a:latin typeface="Arial"/>
               </a:rPr>
-              <a:t>$35-$45/mo</a:t>
+              <a:t>Two-way conversion</a:t>
             </a:r>
             <a:endParaRPr lang="en-US" sz="1100"/>
           </a:p>
@@ -4440,7 +4440,7 @@
                 </a:solidFill>
                 <a:latin typeface="Arial"/>
               </a:rPr>
-              <a:t>OpenAI</a:t>
+              <a:t>Profile</a:t>
             </a:r>
             <a:endParaRPr lang="en-US" sz="1300"/>
           </a:p>
@@ -4477,7 +4477,7 @@
                 </a:solidFill>
                 <a:latin typeface="Arial"/>
               </a:rPr>
-              <a:t>Not required</a:t>
+              <a:t>Agent names</a:t>
             </a:r>
             <a:endParaRPr lang="en-US" sz="1100"/>
           </a:p>
@@ -4638,7 +4638,7 @@
                 </a:solidFill>
                 <a:latin typeface="Arial"/>
               </a:rPr>
-              <a:t>The next development track is operational maturity</a:t>
+              <a:t>QA and health checks make releases safer</a:t>
             </a:r>
             <a:endParaRPr lang="en-US" sz="3500"/>
           </a:p>
@@ -4675,7 +4675,7 @@
                 </a:solidFill>
                 <a:latin typeface="Arial"/>
               </a:rPr>
-              <a:t>The roadmap focuses on reliability and agent speed, not extra manual admin work.</a:t>
+              <a:t>The project now has repeatable checks before deployment.</a:t>
             </a:r>
             <a:endParaRPr lang="en-US" sz="1700"/>
           </a:p>
@@ -4712,7 +4712,7 @@
                 </a:solidFill>
                 <a:latin typeface="Arial"/>
               </a:rPr>
-              <a:t>- Browser extension connected to the hub can replace TextBlaze-style local snippets.</a:t>
+              <a:t>- npm run build verifies Prisma, Next.js, type checking, and static generation.</a:t>
             </a:r>
             <a:endParaRPr lang="en-US" sz="1700"/>
           </a:p>
@@ -4725,7 +4725,7 @@
                 </a:solidFill>
                 <a:latin typeface="Arial"/>
               </a:rPr>
-              <a:t>- Health checks monitor AI configuration, cron setup, and offer-sync freshness.</a:t>
+              <a:t>- npm run smoke verifies page rendering and anonymous API protection.</a:t>
             </a:r>
             <a:endParaRPr lang="en-US" sz="1700"/>
           </a:p>
@@ -4738,20 +4738,33 @@
                 </a:solidFill>
                 <a:latin typeface="Arial"/>
               </a:rPr>
+              <a:t>- Authenticated smoke can run with SMOKE_EMAIL and SMOKE_PASSWORD.</a:t>
+            </a:r>
+            <a:endParaRPr lang="en-US" sz="1700"/>
+          </a:p>
+          <a:p>
+            <a:pPr marL="228600" indent="-171450"/>
+            <a:r>
+              <a:rPr lang="en-US" sz="1700">
+                <a:solidFill>
+                  <a:srgbClr val="111827"/>
+                </a:solidFill>
+                <a:latin typeface="Arial"/>
+              </a:rPr>
+              <a:t>- /api/health reports database, AI configuration, and system readiness.</a:t>
+            </a:r>
+            <a:endParaRPr lang="en-US" sz="1700"/>
+          </a:p>
+          <a:p>
+            <a:pPr marL="228600" indent="-171450"/>
+            <a:r>
+              <a:rPr lang="en-US" sz="1700">
+                <a:solidFill>
+                  <a:srgbClr val="111827"/>
+                </a:solidFill>
+                <a:latin typeface="Arial"/>
+              </a:rPr>
               <a:t>- Legacy UserQuickScript cleanup runs only after Neon audit confirms no unique user data is needed.</a:t>
-            </a:r>
-            <a:endParaRPr lang="en-US" sz="1700"/>
-          </a:p>
-          <a:p>
-            <a:pPr marL="228600" indent="-171450"/>
-            <a:r>
-              <a:rPr lang="en-US" sz="1700">
-                <a:solidFill>
-                  <a:srgbClr val="111827"/>
-                </a:solidFill>
-                <a:latin typeface="Arial"/>
-              </a:rPr>
-              <a:t>- Documentation should keep matching the deployed behavior after each batch.</a:t>
             </a:r>
             <a:endParaRPr lang="en-US" sz="1700"/>
           </a:p>
@@ -4920,7 +4933,7 @@
                 </a:solidFill>
                 <a:latin typeface="Arial"/>
               </a:rPr>
-              <a:t>Extension</a:t>
+              <a:t>Build</a:t>
             </a:r>
             <a:endParaRPr lang="en-US" sz="1300"/>
           </a:p>
@@ -4957,7 +4970,7 @@
                 </a:solidFill>
                 <a:latin typeface="Arial"/>
               </a:rPr>
-              <a:t>Central shortcuts</a:t>
+              <a:t>Production compile</a:t>
             </a:r>
             <a:endParaRPr lang="en-US" sz="1100"/>
           </a:p>
@@ -5023,7 +5036,7 @@
                 </a:solidFill>
                 <a:latin typeface="Arial"/>
               </a:rPr>
-              <a:t>Monitoring</a:t>
+              <a:t>Smoke</a:t>
             </a:r>
             <a:endParaRPr lang="en-US" sz="1300"/>
           </a:p>
@@ -5060,7 +5073,7 @@
                 </a:solidFill>
                 <a:latin typeface="Arial"/>
               </a:rPr>
-              <a:t>AI, cron, offers</a:t>
+              <a:t>Route protection</a:t>
             </a:r>
             <a:endParaRPr lang="en-US" sz="1100"/>
           </a:p>
@@ -5126,7 +5139,7 @@
                 </a:solidFill>
                 <a:latin typeface="Arial"/>
               </a:rPr>
-              <a:t>Cleanup</a:t>
+              <a:t>Health</a:t>
             </a:r>
             <a:endParaRPr lang="en-US" sz="1300"/>
           </a:p>
@@ -5163,7 +5176,7 @@
                 </a:solidFill>
                 <a:latin typeface="Arial"/>
               </a:rPr>
-              <a:t>Audit before delete</a:t>
+              <a:t>Monitor-ready</a:t>
             </a:r>
             <a:endParaRPr lang="en-US" sz="1100"/>
           </a:p>

</xml_diff>

<commit_message>
Add operating cost details to project docs
</commit_message>
<xml_diff>
--- a/docs/PureGym-Support-Hub-Presentation.pptx
+++ b/docs/PureGym-Support-Hub-Presentation.pptx
@@ -2,7 +2,7 @@
 <file path=ppt/presentation.xml><?xml version="1.0" encoding="utf-8"?>
 <p:presentation xmlns:a="http://schemas.openxmlformats.org/drawingml/2006/main" xmlns:r="http://schemas.openxmlformats.org/officeDocument/2006/relationships" xmlns:p="http://schemas.openxmlformats.org/presentationml/2006/main">
   <p:sldMasterIdLst>
-    <p:sldMasterId id="2147483648" r:id="rId9"/>
+    <p:sldMasterId id="2147483648" r:id="rId10"/>
   </p:sldMasterIdLst>
   <p:sldIdLst>
     <p:sldId id="256" r:id="rId1"/>
@@ -13,6 +13,7 @@
     <p:sldId id="261" r:id="rId6"/>
     <p:sldId id="262" r:id="rId7"/>
     <p:sldId id="263" r:id="rId8"/>
+    <p:sldId id="264" r:id="rId9"/>
   </p:sldIdLst>
   <p:sldSz cx="12191999" cy="6858000" type="screen16x9"/>
   <p:notesSz cx="6858000" cy="9144000"/>
@@ -127,7 +128,7 @@
         <p:spPr>
           <a:xfrm>
             <a:off x="6766560" y="0"/>
-            <a:ext cx="5440680" cy="6858000"/>
+            <a:ext cx="5422392" cy="6858000"/>
           </a:xfrm>
           <a:prstGeom prst="rect">
             <a:avLst/>
@@ -436,7 +437,7 @@
         <p:spPr>
           <a:xfrm>
             <a:off x="6583680" y="0"/>
-            <a:ext cx="5669280" cy="146304"/>
+            <a:ext cx="5605272" cy="146304"/>
           </a:xfrm>
           <a:prstGeom prst="rect">
             <a:avLst/>
@@ -1122,7 +1123,7 @@
         <p:spPr>
           <a:xfrm>
             <a:off x="6583680" y="0"/>
-            <a:ext cx="5669280" cy="146304"/>
+            <a:ext cx="5605272" cy="146304"/>
           </a:xfrm>
           <a:prstGeom prst="rect">
             <a:avLst/>
@@ -1808,7 +1809,7 @@
         <p:spPr>
           <a:xfrm>
             <a:off x="6583680" y="0"/>
-            <a:ext cx="5669280" cy="146304"/>
+            <a:ext cx="5605272" cy="146304"/>
           </a:xfrm>
           <a:prstGeom prst="rect">
             <a:avLst/>
@@ -2494,7 +2495,7 @@
         <p:spPr>
           <a:xfrm>
             <a:off x="6583680" y="0"/>
-            <a:ext cx="5669280" cy="146304"/>
+            <a:ext cx="5605272" cy="146304"/>
           </a:xfrm>
           <a:prstGeom prst="rect">
             <a:avLst/>
@@ -3180,7 +3181,7 @@
         <p:spPr>
           <a:xfrm>
             <a:off x="6583680" y="0"/>
-            <a:ext cx="5669280" cy="146304"/>
+            <a:ext cx="5605272" cy="146304"/>
           </a:xfrm>
           <a:prstGeom prst="rect">
             <a:avLst/>
@@ -3353,7 +3354,7 @@
                 </a:solidFill>
                 <a:latin typeface="Arial"/>
               </a:rPr>
-              <a:t>- User creation, removal, and role changes are left to the development team.</a:t>
+              <a:t>- User creation, removal, and role changes are left to the technical team.</a:t>
             </a:r>
             <a:endParaRPr lang="en-US" sz="1700"/>
           </a:p>
@@ -3651,7 +3652,7 @@
                 </a:solidFill>
                 <a:latin typeface="Arial"/>
               </a:rPr>
-              <a:t>Developers</a:t>
+              <a:t>Technical team</a:t>
             </a:r>
             <a:endParaRPr lang="en-US" sz="1300"/>
           </a:p>
@@ -3866,7 +3867,7 @@
         <p:spPr>
           <a:xfrm>
             <a:off x="6583680" y="0"/>
-            <a:ext cx="5669280" cy="146304"/>
+            <a:ext cx="5605272" cy="146304"/>
           </a:xfrm>
           <a:prstGeom prst="rect">
             <a:avLst/>
@@ -4552,7 +4553,7 @@
         <p:spPr>
           <a:xfrm>
             <a:off x="6583680" y="0"/>
-            <a:ext cx="5669280" cy="146304"/>
+            <a:ext cx="5605272" cy="146304"/>
           </a:xfrm>
           <a:prstGeom prst="rect">
             <a:avLst/>
@@ -5177,6 +5178,705 @@
                 <a:latin typeface="Arial"/>
               </a:rPr>
               <a:t>Monitor-ready</a:t>
+            </a:r>
+            <a:endParaRPr lang="en-US" sz="1100"/>
+          </a:p>
+        </p:txBody>
+      </p:sp>
+    </p:spTree>
+  </p:cSld>
+  <p:clrMapOvr>
+    <a:masterClrMapping/>
+  </p:clrMapOvr>
+</p:sld>
+</file>
+
+<file path=ppt/slides/slide9.xml><?xml version="1.0" encoding="utf-8"?>
+<p:sld xmlns:a="http://schemas.openxmlformats.org/drawingml/2006/main" xmlns:r="http://schemas.openxmlformats.org/officeDocument/2006/relationships" xmlns:p="http://schemas.openxmlformats.org/presentationml/2006/main">
+  <p:cSld>
+    <p:bg>
+      <p:bgPr>
+        <a:solidFill>
+          <a:srgbClr val="FFFFFF"/>
+        </a:solidFill>
+        <a:effectLst/>
+      </p:bgPr>
+    </p:bg>
+    <p:spTree>
+      <p:nvGrpSpPr>
+        <p:cNvPr id="1" name=""/>
+        <p:cNvGrpSpPr/>
+        <p:nvPr/>
+      </p:nvGrpSpPr>
+      <p:grpSpPr>
+        <a:xfrm>
+          <a:off x="0" y="0"/>
+          <a:ext cx="0" cy="0"/>
+          <a:chOff x="0" y="0"/>
+          <a:chExt cx="0" cy="0"/>
+        </a:xfrm>
+      </p:grpSpPr>
+      <p:sp>
+        <p:nvSpPr>
+          <p:cNvPr id="2" name="top-accent-green"/>
+          <p:cNvSpPr/>
+          <p:nvPr/>
+        </p:nvSpPr>
+        <p:spPr>
+          <a:xfrm>
+            <a:off x="0" y="0"/>
+            <a:ext cx="6583680" cy="146304"/>
+          </a:xfrm>
+          <a:prstGeom prst="rect">
+            <a:avLst/>
+          </a:prstGeom>
+          <a:solidFill>
+            <a:srgbClr val="00A651"/>
+          </a:solidFill>
+          <a:ln>
+            <a:noFill/>
+          </a:ln>
+        </p:spPr>
+        <p:txBody>
+          <a:bodyPr/>
+          <a:lstStyle/>
+          <a:p/>
+        </p:txBody>
+      </p:sp>
+      <p:sp>
+        <p:nvSpPr>
+          <p:cNvPr id="3" name="top-accent-blue"/>
+          <p:cNvSpPr/>
+          <p:nvPr/>
+        </p:nvSpPr>
+        <p:spPr>
+          <a:xfrm>
+            <a:off x="6583680" y="0"/>
+            <a:ext cx="5605272" cy="146304"/>
+          </a:xfrm>
+          <a:prstGeom prst="rect">
+            <a:avLst/>
+          </a:prstGeom>
+          <a:solidFill>
+            <a:srgbClr val="005EB8"/>
+          </a:solidFill>
+          <a:ln>
+            <a:noFill/>
+          </a:ln>
+        </p:spPr>
+        <p:txBody>
+          <a:bodyPr/>
+          <a:lstStyle/>
+          <a:p/>
+        </p:txBody>
+      </p:sp>
+      <p:sp>
+        <p:nvSpPr>
+          <p:cNvPr id="4" name="eyebrow"/>
+          <p:cNvSpPr txBox="1"/>
+          <p:nvPr/>
+        </p:nvSpPr>
+        <p:spPr>
+          <a:xfrm>
+            <a:off x="530352" y="329184"/>
+            <a:ext cx="4937760" cy="274320"/>
+          </a:xfrm>
+          <a:prstGeom prst="rect">
+            <a:avLst/>
+          </a:prstGeom>
+          <a:noFill/>
+          <a:ln>
+            <a:noFill/>
+          </a:ln>
+        </p:spPr>
+        <p:txBody>
+          <a:bodyPr wrap="square" anchor="t"/>
+          <a:lstStyle/>
+          <a:p>
+            <a:pPr algn="l"/>
+            <a:r>
+              <a:rPr lang="en-US" sz="1000" b="1">
+                <a:solidFill>
+                  <a:srgbClr val="4B5563"/>
+                </a:solidFill>
+                <a:latin typeface="Arial"/>
+              </a:rPr>
+              <a:t>PUREGYM SUPPORT HUB</a:t>
+            </a:r>
+            <a:endParaRPr lang="en-US" sz="1000"/>
+          </a:p>
+        </p:txBody>
+      </p:sp>
+      <p:sp>
+        <p:nvSpPr>
+          <p:cNvPr id="5" name="title"/>
+          <p:cNvSpPr txBox="1"/>
+          <p:nvPr/>
+        </p:nvSpPr>
+        <p:spPr>
+          <a:xfrm>
+            <a:off x="530352" y="786384"/>
+            <a:ext cx="7589520" cy="1005840"/>
+          </a:xfrm>
+          <a:prstGeom prst="rect">
+            <a:avLst/>
+          </a:prstGeom>
+          <a:noFill/>
+          <a:ln>
+            <a:noFill/>
+          </a:ln>
+        </p:spPr>
+        <p:txBody>
+          <a:bodyPr wrap="square" anchor="t"/>
+          <a:lstStyle/>
+          <a:p>
+            <a:pPr algn="l"/>
+            <a:r>
+              <a:rPr lang="en-US" sz="3500" b="1">
+                <a:solidFill>
+                  <a:srgbClr val="111827"/>
+                </a:solidFill>
+                <a:latin typeface="Arial"/>
+              </a:rPr>
+              <a:t>Operating cost stays small for 25 users</a:t>
+            </a:r>
+            <a:endParaRPr lang="en-US" sz="3500"/>
+          </a:p>
+        </p:txBody>
+      </p:sp>
+      <p:sp>
+        <p:nvSpPr>
+          <p:cNvPr id="6" name="subtitle"/>
+          <p:cNvSpPr txBox="1"/>
+          <p:nvPr/>
+        </p:nvSpPr>
+        <p:spPr>
+          <a:xfrm>
+            <a:off x="548640" y="1737360"/>
+            <a:ext cx="8595360" cy="502920"/>
+          </a:xfrm>
+          <a:prstGeom prst="rect">
+            <a:avLst/>
+          </a:prstGeom>
+          <a:noFill/>
+          <a:ln>
+            <a:noFill/>
+          </a:ln>
+        </p:spPr>
+        <p:txBody>
+          <a:bodyPr wrap="square" anchor="t"/>
+          <a:lstStyle/>
+          <a:p>
+            <a:pPr algn="l"/>
+            <a:r>
+              <a:rPr lang="en-US" sz="1700">
+                <a:solidFill>
+                  <a:srgbClr val="4B5563"/>
+                </a:solidFill>
+                <a:latin typeface="Arial"/>
+              </a:rPr>
+              <a:t>The main monthly cost is hosting, database capacity, and AI usage.</a:t>
+            </a:r>
+            <a:endParaRPr lang="en-US" sz="1700"/>
+          </a:p>
+        </p:txBody>
+      </p:sp>
+      <p:sp>
+        <p:nvSpPr>
+          <p:cNvPr id="7" name="bullets"/>
+          <p:cNvSpPr txBox="1"/>
+          <p:nvPr/>
+        </p:nvSpPr>
+        <p:spPr>
+          <a:xfrm>
+            <a:off x="713232" y="2514600"/>
+            <a:ext cx="5577840" cy="3474720"/>
+          </a:xfrm>
+          <a:prstGeom prst="rect">
+            <a:avLst/>
+          </a:prstGeom>
+          <a:noFill/>
+          <a:ln>
+            <a:noFill/>
+          </a:ln>
+        </p:spPr>
+        <p:txBody>
+          <a:bodyPr wrap="square" anchor="t"/>
+          <a:lstStyle/>
+          <a:p>
+            <a:pPr marL="228600" indent="-171450"/>
+            <a:r>
+              <a:rPr lang="en-US" sz="1700">
+                <a:solidFill>
+                  <a:srgbClr val="111827"/>
+                </a:solidFill>
+                <a:latin typeface="Arial"/>
+              </a:rPr>
+              <a:t>- Hosting: Vercel can be $0/mo for light internal use, or $20/mo on Pro for production control.</a:t>
+            </a:r>
+            <a:endParaRPr lang="en-US" sz="1700"/>
+          </a:p>
+          <a:p>
+            <a:pPr marL="228600" indent="-171450"/>
+            <a:r>
+              <a:rPr lang="en-US" sz="1700">
+                <a:solidFill>
+                  <a:srgbClr val="111827"/>
+                </a:solidFill>
+                <a:latin typeface="Arial"/>
+              </a:rPr>
+              <a:t>- Database: Neon can start at $0/mo; Launch is typically about $15/mo for intermittent load and 1 GB.</a:t>
+            </a:r>
+            <a:endParaRPr lang="en-US" sz="1700"/>
+          </a:p>
+          <a:p>
+            <a:pPr marL="228600" indent="-171450"/>
+            <a:r>
+              <a:rPr lang="en-US" sz="1700">
+                <a:solidFill>
+                  <a:srgbClr val="111827"/>
+                </a:solidFill>
+                <a:latin typeface="Arial"/>
+              </a:rPr>
+              <a:t>- AI: Groq Llama 3.1 8B is $0.05 per 1M input tokens and $0.08 per 1M output tokens.</a:t>
+            </a:r>
+            <a:endParaRPr lang="en-US" sz="1700"/>
+          </a:p>
+          <a:p>
+            <a:pPr marL="228600" indent="-171450"/>
+            <a:r>
+              <a:rPr lang="en-US" sz="1700">
+                <a:solidFill>
+                  <a:srgbClr val="111827"/>
+                </a:solidFill>
+                <a:latin typeface="Arial"/>
+              </a:rPr>
+              <a:t>- 25-user example: 15,000 AI calls/month at moderate token size is about $2/mo on Groq.</a:t>
+            </a:r>
+            <a:endParaRPr lang="en-US" sz="1700"/>
+          </a:p>
+          <a:p>
+            <a:pPr marL="228600" indent="-171450"/>
+            <a:r>
+              <a:rPr lang="en-US" sz="1700">
+                <a:solidFill>
+                  <a:srgbClr val="111827"/>
+                </a:solidFill>
+                <a:latin typeface="Arial"/>
+              </a:rPr>
+              <a:t>- Practical budget: $0-$10/mo lean, or about $35-$45/mo for a safer production baseline.</a:t>
+            </a:r>
+            <a:endParaRPr lang="en-US" sz="1700"/>
+          </a:p>
+        </p:txBody>
+      </p:sp>
+      <p:sp>
+        <p:nvSpPr>
+          <p:cNvPr id="8" name="side-panel"/>
+          <p:cNvSpPr/>
+          <p:nvPr/>
+        </p:nvSpPr>
+        <p:spPr>
+          <a:xfrm>
+            <a:off x="6629400" y="2423160"/>
+            <a:ext cx="4983480" cy="3246120"/>
+          </a:xfrm>
+          <a:prstGeom prst="rect">
+            <a:avLst/>
+          </a:prstGeom>
+          <a:solidFill>
+            <a:srgbClr val="F3F6F8"/>
+          </a:solidFill>
+          <a:ln w="9525">
+            <a:solidFill>
+              <a:srgbClr val="D7DEE8"/>
+            </a:solidFill>
+          </a:ln>
+        </p:spPr>
+        <p:txBody>
+          <a:bodyPr/>
+          <a:lstStyle/>
+          <a:p/>
+        </p:txBody>
+      </p:sp>
+      <p:sp>
+        <p:nvSpPr>
+          <p:cNvPr id="9" name="slide-number"/>
+          <p:cNvSpPr txBox="1"/>
+          <p:nvPr/>
+        </p:nvSpPr>
+        <p:spPr>
+          <a:xfrm>
+            <a:off x="11173968" y="6364224"/>
+            <a:ext cx="502920" cy="182880"/>
+          </a:xfrm>
+          <a:prstGeom prst="rect">
+            <a:avLst/>
+          </a:prstGeom>
+          <a:noFill/>
+          <a:ln>
+            <a:noFill/>
+          </a:ln>
+        </p:spPr>
+        <p:txBody>
+          <a:bodyPr wrap="square" anchor="t"/>
+          <a:lstStyle/>
+          <a:p>
+            <a:pPr algn="l"/>
+            <a:r>
+              <a:rPr lang="en-US" sz="900">
+                <a:solidFill>
+                  <a:srgbClr val="4B5563"/>
+                </a:solidFill>
+                <a:latin typeface="Arial"/>
+              </a:rPr>
+              <a:t>9</a:t>
+            </a:r>
+            <a:endParaRPr lang="en-US" sz="900"/>
+          </a:p>
+        </p:txBody>
+      </p:sp>
+      <p:sp>
+        <p:nvSpPr>
+          <p:cNvPr id="10" name="made-by"/>
+          <p:cNvSpPr txBox="1"/>
+          <p:nvPr/>
+        </p:nvSpPr>
+        <p:spPr>
+          <a:xfrm>
+            <a:off x="530352" y="6327648"/>
+            <a:ext cx="3840480" cy="228600"/>
+          </a:xfrm>
+          <a:prstGeom prst="rect">
+            <a:avLst/>
+          </a:prstGeom>
+          <a:noFill/>
+          <a:ln>
+            <a:noFill/>
+          </a:ln>
+        </p:spPr>
+        <p:txBody>
+          <a:bodyPr wrap="square" anchor="t"/>
+          <a:lstStyle/>
+          <a:p>
+            <a:pPr algn="l"/>
+            <a:r>
+              <a:rPr lang="en-US" sz="900">
+                <a:solidFill>
+                  <a:srgbClr val="4B5563"/>
+                </a:solidFill>
+                <a:latin typeface="Arial"/>
+              </a:rPr>
+              <a:t>Made by Mohammed Alkhandagji</a:t>
+            </a:r>
+            <a:endParaRPr lang="en-US" sz="900"/>
+          </a:p>
+        </p:txBody>
+      </p:sp>
+      <p:sp>
+        <p:nvSpPr>
+          <p:cNvPr id="11" name="card-11"/>
+          <p:cNvSpPr/>
+          <p:nvPr/>
+        </p:nvSpPr>
+        <p:spPr>
+          <a:xfrm>
+            <a:off x="6931152" y="2651760"/>
+            <a:ext cx="4370832" cy="804672"/>
+          </a:xfrm>
+          <a:prstGeom prst="rect">
+            <a:avLst/>
+          </a:prstGeom>
+          <a:solidFill>
+            <a:srgbClr val="FFFFFF"/>
+          </a:solidFill>
+          <a:ln w="9525">
+            <a:solidFill>
+              <a:srgbClr val="D7DEE8"/>
+            </a:solidFill>
+          </a:ln>
+        </p:spPr>
+        <p:txBody>
+          <a:bodyPr/>
+          <a:lstStyle/>
+          <a:p/>
+        </p:txBody>
+      </p:sp>
+      <p:sp>
+        <p:nvSpPr>
+          <p:cNvPr id="12" name="card-title-11"/>
+          <p:cNvSpPr txBox="1"/>
+          <p:nvPr/>
+        </p:nvSpPr>
+        <p:spPr>
+          <a:xfrm>
+            <a:off x="7114032" y="2779776"/>
+            <a:ext cx="3977639" cy="201168"/>
+          </a:xfrm>
+          <a:prstGeom prst="rect">
+            <a:avLst/>
+          </a:prstGeom>
+          <a:noFill/>
+          <a:ln>
+            <a:noFill/>
+          </a:ln>
+        </p:spPr>
+        <p:txBody>
+          <a:bodyPr wrap="square" anchor="t"/>
+          <a:lstStyle/>
+          <a:p>
+            <a:pPr algn="l"/>
+            <a:r>
+              <a:rPr lang="en-US" sz="1300" b="1">
+                <a:solidFill>
+                  <a:srgbClr val="005EB8"/>
+                </a:solidFill>
+                <a:latin typeface="Arial"/>
+              </a:rPr>
+              <a:t>Vercel</a:t>
+            </a:r>
+            <a:endParaRPr lang="en-US" sz="1300"/>
+          </a:p>
+        </p:txBody>
+      </p:sp>
+      <p:sp>
+        <p:nvSpPr>
+          <p:cNvPr id="13" name="card-body-11"/>
+          <p:cNvSpPr txBox="1"/>
+          <p:nvPr/>
+        </p:nvSpPr>
+        <p:spPr>
+          <a:xfrm>
+            <a:off x="7114032" y="3035808"/>
+            <a:ext cx="3977639" cy="219456"/>
+          </a:xfrm>
+          <a:prstGeom prst="rect">
+            <a:avLst/>
+          </a:prstGeom>
+          <a:noFill/>
+          <a:ln>
+            <a:noFill/>
+          </a:ln>
+        </p:spPr>
+        <p:txBody>
+          <a:bodyPr wrap="square" anchor="t"/>
+          <a:lstStyle/>
+          <a:p>
+            <a:pPr algn="l"/>
+            <a:r>
+              <a:rPr lang="en-US" sz="1100">
+                <a:solidFill>
+                  <a:srgbClr val="4B5563"/>
+                </a:solidFill>
+                <a:latin typeface="Arial"/>
+              </a:rPr>
+              <a:t>$0 or $20/mo</a:t>
+            </a:r>
+            <a:endParaRPr lang="en-US" sz="1100"/>
+          </a:p>
+        </p:txBody>
+      </p:sp>
+      <p:sp>
+        <p:nvSpPr>
+          <p:cNvPr id="14" name="card-14"/>
+          <p:cNvSpPr/>
+          <p:nvPr/>
+        </p:nvSpPr>
+        <p:spPr>
+          <a:xfrm>
+            <a:off x="6931152" y="3611880"/>
+            <a:ext cx="4370832" cy="804672"/>
+          </a:xfrm>
+          <a:prstGeom prst="rect">
+            <a:avLst/>
+          </a:prstGeom>
+          <a:solidFill>
+            <a:srgbClr val="FFFFFF"/>
+          </a:solidFill>
+          <a:ln w="9525">
+            <a:solidFill>
+              <a:srgbClr val="D7DEE8"/>
+            </a:solidFill>
+          </a:ln>
+        </p:spPr>
+        <p:txBody>
+          <a:bodyPr/>
+          <a:lstStyle/>
+          <a:p/>
+        </p:txBody>
+      </p:sp>
+      <p:sp>
+        <p:nvSpPr>
+          <p:cNvPr id="15" name="card-title-14"/>
+          <p:cNvSpPr txBox="1"/>
+          <p:nvPr/>
+        </p:nvSpPr>
+        <p:spPr>
+          <a:xfrm>
+            <a:off x="7114032" y="3739896"/>
+            <a:ext cx="3977639" cy="201168"/>
+          </a:xfrm>
+          <a:prstGeom prst="rect">
+            <a:avLst/>
+          </a:prstGeom>
+          <a:noFill/>
+          <a:ln>
+            <a:noFill/>
+          </a:ln>
+        </p:spPr>
+        <p:txBody>
+          <a:bodyPr wrap="square" anchor="t"/>
+          <a:lstStyle/>
+          <a:p>
+            <a:pPr algn="l"/>
+            <a:r>
+              <a:rPr lang="en-US" sz="1300" b="1">
+                <a:solidFill>
+                  <a:srgbClr val="005EB8"/>
+                </a:solidFill>
+                <a:latin typeface="Arial"/>
+              </a:rPr>
+              <a:t>Neon</a:t>
+            </a:r>
+            <a:endParaRPr lang="en-US" sz="1300"/>
+          </a:p>
+        </p:txBody>
+      </p:sp>
+      <p:sp>
+        <p:nvSpPr>
+          <p:cNvPr id="16" name="card-body-14"/>
+          <p:cNvSpPr txBox="1"/>
+          <p:nvPr/>
+        </p:nvSpPr>
+        <p:spPr>
+          <a:xfrm>
+            <a:off x="7114032" y="3995928"/>
+            <a:ext cx="3977639" cy="219456"/>
+          </a:xfrm>
+          <a:prstGeom prst="rect">
+            <a:avLst/>
+          </a:prstGeom>
+          <a:noFill/>
+          <a:ln>
+            <a:noFill/>
+          </a:ln>
+        </p:spPr>
+        <p:txBody>
+          <a:bodyPr wrap="square" anchor="t"/>
+          <a:lstStyle/>
+          <a:p>
+            <a:pPr algn="l"/>
+            <a:r>
+              <a:rPr lang="en-US" sz="1100">
+                <a:solidFill>
+                  <a:srgbClr val="4B5563"/>
+                </a:solidFill>
+                <a:latin typeface="Arial"/>
+              </a:rPr>
+              <a:t>$0 or ~$15/mo</a:t>
+            </a:r>
+            <a:endParaRPr lang="en-US" sz="1100"/>
+          </a:p>
+        </p:txBody>
+      </p:sp>
+      <p:sp>
+        <p:nvSpPr>
+          <p:cNvPr id="17" name="card-17"/>
+          <p:cNvSpPr/>
+          <p:nvPr/>
+        </p:nvSpPr>
+        <p:spPr>
+          <a:xfrm>
+            <a:off x="6931152" y="4572000"/>
+            <a:ext cx="4370832" cy="804672"/>
+          </a:xfrm>
+          <a:prstGeom prst="rect">
+            <a:avLst/>
+          </a:prstGeom>
+          <a:solidFill>
+            <a:srgbClr val="FFFFFF"/>
+          </a:solidFill>
+          <a:ln w="9525">
+            <a:solidFill>
+              <a:srgbClr val="D7DEE8"/>
+            </a:solidFill>
+          </a:ln>
+        </p:spPr>
+        <p:txBody>
+          <a:bodyPr/>
+          <a:lstStyle/>
+          <a:p/>
+        </p:txBody>
+      </p:sp>
+      <p:sp>
+        <p:nvSpPr>
+          <p:cNvPr id="18" name="card-title-17"/>
+          <p:cNvSpPr txBox="1"/>
+          <p:nvPr/>
+        </p:nvSpPr>
+        <p:spPr>
+          <a:xfrm>
+            <a:off x="7114032" y="4700016"/>
+            <a:ext cx="3977639" cy="201168"/>
+          </a:xfrm>
+          <a:prstGeom prst="rect">
+            <a:avLst/>
+          </a:prstGeom>
+          <a:noFill/>
+          <a:ln>
+            <a:noFill/>
+          </a:ln>
+        </p:spPr>
+        <p:txBody>
+          <a:bodyPr wrap="square" anchor="t"/>
+          <a:lstStyle/>
+          <a:p>
+            <a:pPr algn="l"/>
+            <a:r>
+              <a:rPr lang="en-US" sz="1300" b="1">
+                <a:solidFill>
+                  <a:srgbClr val="005EB8"/>
+                </a:solidFill>
+                <a:latin typeface="Arial"/>
+              </a:rPr>
+              <a:t>AI</a:t>
+            </a:r>
+            <a:endParaRPr lang="en-US" sz="1300"/>
+          </a:p>
+        </p:txBody>
+      </p:sp>
+      <p:sp>
+        <p:nvSpPr>
+          <p:cNvPr id="19" name="card-body-17"/>
+          <p:cNvSpPr txBox="1"/>
+          <p:nvPr/>
+        </p:nvSpPr>
+        <p:spPr>
+          <a:xfrm>
+            <a:off x="7114032" y="4956048"/>
+            <a:ext cx="3977639" cy="219456"/>
+          </a:xfrm>
+          <a:prstGeom prst="rect">
+            <a:avLst/>
+          </a:prstGeom>
+          <a:noFill/>
+          <a:ln>
+            <a:noFill/>
+          </a:ln>
+        </p:spPr>
+        <p:txBody>
+          <a:bodyPr wrap="square" anchor="t"/>
+          <a:lstStyle/>
+          <a:p>
+            <a:pPr algn="l"/>
+            <a:r>
+              <a:rPr lang="en-US" sz="1100">
+                <a:solidFill>
+                  <a:srgbClr val="4B5563"/>
+                </a:solidFill>
+                <a:latin typeface="Arial"/>
+              </a:rPr>
+              <a:t>~$2-$10/mo</a:t>
             </a:r>
             <a:endParaRPr lang="en-US" sz="1100"/>
           </a:p>

</xml_diff>

<commit_message>
Add closing slide to project presentation
</commit_message>
<xml_diff>
--- a/docs/PureGym-Support-Hub-Presentation.pptx
+++ b/docs/PureGym-Support-Hub-Presentation.pptx
@@ -2,7 +2,7 @@
 <file path=ppt/presentation.xml><?xml version="1.0" encoding="utf-8"?>
 <p:presentation xmlns:a="http://schemas.openxmlformats.org/drawingml/2006/main" xmlns:r="http://schemas.openxmlformats.org/officeDocument/2006/relationships" xmlns:p="http://schemas.openxmlformats.org/presentationml/2006/main">
   <p:sldMasterIdLst>
-    <p:sldMasterId id="2147483648" r:id="rId10"/>
+    <p:sldMasterId id="2147483648" r:id="rId11"/>
   </p:sldMasterIdLst>
   <p:sldIdLst>
     <p:sldId id="256" r:id="rId1"/>
@@ -14,6 +14,7 @@
     <p:sldId id="262" r:id="rId7"/>
     <p:sldId id="263" r:id="rId8"/>
     <p:sldId id="264" r:id="rId9"/>
+    <p:sldId id="265" r:id="rId10"/>
   </p:sldIdLst>
   <p:sldSz cx="12191999" cy="6858000" type="screen16x9"/>
   <p:notesSz cx="6858000" cy="9144000"/>
@@ -365,6 +366,692 @@
               <a:t>Built for faster, cleaner support conversations.</a:t>
             </a:r>
             <a:endParaRPr lang="en-US" sz="1800"/>
+          </a:p>
+        </p:txBody>
+      </p:sp>
+    </p:spTree>
+  </p:cSld>
+  <p:clrMapOvr>
+    <a:masterClrMapping/>
+  </p:clrMapOvr>
+</p:sld>
+</file>
+
+<file path=ppt/slides/slide10.xml><?xml version="1.0" encoding="utf-8"?>
+<p:sld xmlns:a="http://schemas.openxmlformats.org/drawingml/2006/main" xmlns:r="http://schemas.openxmlformats.org/officeDocument/2006/relationships" xmlns:p="http://schemas.openxmlformats.org/presentationml/2006/main">
+  <p:cSld>
+    <p:bg>
+      <p:bgPr>
+        <a:solidFill>
+          <a:srgbClr val="FFFFFF"/>
+        </a:solidFill>
+        <a:effectLst/>
+      </p:bgPr>
+    </p:bg>
+    <p:spTree>
+      <p:nvGrpSpPr>
+        <p:cNvPr id="1" name=""/>
+        <p:cNvGrpSpPr/>
+        <p:nvPr/>
+      </p:nvGrpSpPr>
+      <p:grpSpPr>
+        <a:xfrm>
+          <a:off x="0" y="0"/>
+          <a:ext cx="0" cy="0"/>
+          <a:chOff x="0" y="0"/>
+          <a:chExt cx="0" cy="0"/>
+        </a:xfrm>
+      </p:grpSpPr>
+      <p:sp>
+        <p:nvSpPr>
+          <p:cNvPr id="2" name="top-accent-green"/>
+          <p:cNvSpPr/>
+          <p:nvPr/>
+        </p:nvSpPr>
+        <p:spPr>
+          <a:xfrm>
+            <a:off x="0" y="0"/>
+            <a:ext cx="6583680" cy="146304"/>
+          </a:xfrm>
+          <a:prstGeom prst="rect">
+            <a:avLst/>
+          </a:prstGeom>
+          <a:solidFill>
+            <a:srgbClr val="00A651"/>
+          </a:solidFill>
+          <a:ln>
+            <a:noFill/>
+          </a:ln>
+        </p:spPr>
+        <p:txBody>
+          <a:bodyPr/>
+          <a:lstStyle/>
+          <a:p/>
+        </p:txBody>
+      </p:sp>
+      <p:sp>
+        <p:nvSpPr>
+          <p:cNvPr id="3" name="top-accent-blue"/>
+          <p:cNvSpPr/>
+          <p:nvPr/>
+        </p:nvSpPr>
+        <p:spPr>
+          <a:xfrm>
+            <a:off x="6583680" y="0"/>
+            <a:ext cx="5605272" cy="146304"/>
+          </a:xfrm>
+          <a:prstGeom prst="rect">
+            <a:avLst/>
+          </a:prstGeom>
+          <a:solidFill>
+            <a:srgbClr val="005EB8"/>
+          </a:solidFill>
+          <a:ln>
+            <a:noFill/>
+          </a:ln>
+        </p:spPr>
+        <p:txBody>
+          <a:bodyPr/>
+          <a:lstStyle/>
+          <a:p/>
+        </p:txBody>
+      </p:sp>
+      <p:sp>
+        <p:nvSpPr>
+          <p:cNvPr id="4" name="eyebrow"/>
+          <p:cNvSpPr txBox="1"/>
+          <p:nvPr/>
+        </p:nvSpPr>
+        <p:spPr>
+          <a:xfrm>
+            <a:off x="530352" y="329184"/>
+            <a:ext cx="4937760" cy="274320"/>
+          </a:xfrm>
+          <a:prstGeom prst="rect">
+            <a:avLst/>
+          </a:prstGeom>
+          <a:noFill/>
+          <a:ln>
+            <a:noFill/>
+          </a:ln>
+        </p:spPr>
+        <p:txBody>
+          <a:bodyPr wrap="square" anchor="t"/>
+          <a:lstStyle/>
+          <a:p>
+            <a:pPr algn="l"/>
+            <a:r>
+              <a:rPr lang="en-US" sz="1000" b="1">
+                <a:solidFill>
+                  <a:srgbClr val="4B5563"/>
+                </a:solidFill>
+                <a:latin typeface="Arial"/>
+              </a:rPr>
+              <a:t>PUREGYM SUPPORT HUB</a:t>
+            </a:r>
+            <a:endParaRPr lang="en-US" sz="1000"/>
+          </a:p>
+        </p:txBody>
+      </p:sp>
+      <p:sp>
+        <p:nvSpPr>
+          <p:cNvPr id="5" name="title"/>
+          <p:cNvSpPr txBox="1"/>
+          <p:nvPr/>
+        </p:nvSpPr>
+        <p:spPr>
+          <a:xfrm>
+            <a:off x="530352" y="786384"/>
+            <a:ext cx="7589520" cy="1005840"/>
+          </a:xfrm>
+          <a:prstGeom prst="rect">
+            <a:avLst/>
+          </a:prstGeom>
+          <a:noFill/>
+          <a:ln>
+            <a:noFill/>
+          </a:ln>
+        </p:spPr>
+        <p:txBody>
+          <a:bodyPr wrap="square" anchor="t"/>
+          <a:lstStyle/>
+          <a:p>
+            <a:pPr algn="l"/>
+            <a:r>
+              <a:rPr lang="en-US" sz="3500" b="1">
+                <a:solidFill>
+                  <a:srgbClr val="111827"/>
+                </a:solidFill>
+                <a:latin typeface="Arial"/>
+              </a:rPr>
+              <a:t>The hub is ready for daily support work</a:t>
+            </a:r>
+            <a:endParaRPr lang="en-US" sz="3500"/>
+          </a:p>
+        </p:txBody>
+      </p:sp>
+      <p:sp>
+        <p:nvSpPr>
+          <p:cNvPr id="6" name="subtitle"/>
+          <p:cNvSpPr txBox="1"/>
+          <p:nvPr/>
+        </p:nvSpPr>
+        <p:spPr>
+          <a:xfrm>
+            <a:off x="548640" y="1737360"/>
+            <a:ext cx="8595360" cy="502920"/>
+          </a:xfrm>
+          <a:prstGeom prst="rect">
+            <a:avLst/>
+          </a:prstGeom>
+          <a:noFill/>
+          <a:ln>
+            <a:noFill/>
+          </a:ln>
+        </p:spPr>
+        <p:txBody>
+          <a:bodyPr wrap="square" anchor="t"/>
+          <a:lstStyle/>
+          <a:p>
+            <a:pPr algn="l"/>
+            <a:r>
+              <a:rPr lang="en-US" sz="1700">
+                <a:solidFill>
+                  <a:srgbClr val="4B5563"/>
+                </a:solidFill>
+                <a:latin typeface="Arial"/>
+              </a:rPr>
+              <a:t>The final result is a cleaner, faster workspace for agents and admins.</a:t>
+            </a:r>
+            <a:endParaRPr lang="en-US" sz="1700"/>
+          </a:p>
+        </p:txBody>
+      </p:sp>
+      <p:sp>
+        <p:nvSpPr>
+          <p:cNvPr id="7" name="bullets"/>
+          <p:cNvSpPr txBox="1"/>
+          <p:nvPr/>
+        </p:nvSpPr>
+        <p:spPr>
+          <a:xfrm>
+            <a:off x="713232" y="2514600"/>
+            <a:ext cx="5577840" cy="3474720"/>
+          </a:xfrm>
+          <a:prstGeom prst="rect">
+            <a:avLst/>
+          </a:prstGeom>
+          <a:noFill/>
+          <a:ln>
+            <a:noFill/>
+          </a:ln>
+        </p:spPr>
+        <p:txBody>
+          <a:bodyPr wrap="square" anchor="t"/>
+          <a:lstStyle/>
+          <a:p>
+            <a:pPr marL="228600" indent="-171450"/>
+            <a:r>
+              <a:rPr lang="en-US" sz="1700">
+                <a:solidFill>
+                  <a:srgbClr val="111827"/>
+                </a:solidFill>
+                <a:latin typeface="Arial"/>
+              </a:rPr>
+              <a:t>- Agents can search, fill, copy, calculate, and use AI from one focused dashboard.</a:t>
+            </a:r>
+            <a:endParaRPr lang="en-US" sz="1700"/>
+          </a:p>
+          <a:p>
+            <a:pPr marL="228600" indent="-171450"/>
+            <a:r>
+              <a:rPr lang="en-US" sz="1700">
+                <a:solidFill>
+                  <a:srgbClr val="111827"/>
+                </a:solidFill>
+                <a:latin typeface="Arial"/>
+              </a:rPr>
+              <a:t>- Admins can keep scripts, categories, quick replies, and shared references clean.</a:t>
+            </a:r>
+            <a:endParaRPr lang="en-US" sz="1700"/>
+          </a:p>
+          <a:p>
+            <a:pPr marL="228600" indent="-171450"/>
+            <a:r>
+              <a:rPr lang="en-US" sz="1700">
+                <a:solidFill>
+                  <a:srgbClr val="111827"/>
+                </a:solidFill>
+                <a:latin typeface="Arial"/>
+              </a:rPr>
+              <a:t>- Neon keeps current content live, so deployments do not replace admin updates.</a:t>
+            </a:r>
+            <a:endParaRPr lang="en-US" sz="1700"/>
+          </a:p>
+          <a:p>
+            <a:pPr marL="228600" indent="-171450"/>
+            <a:r>
+              <a:rPr lang="en-US" sz="1700">
+                <a:solidFill>
+                  <a:srgbClr val="111827"/>
+                </a:solidFill>
+                <a:latin typeface="Arial"/>
+              </a:rPr>
+              <a:t>- The operating model stays simple, controlled, and low-cost for a 25-user team.</a:t>
+            </a:r>
+            <a:endParaRPr lang="en-US" sz="1700"/>
+          </a:p>
+        </p:txBody>
+      </p:sp>
+      <p:sp>
+        <p:nvSpPr>
+          <p:cNvPr id="8" name="side-panel"/>
+          <p:cNvSpPr/>
+          <p:nvPr/>
+        </p:nvSpPr>
+        <p:spPr>
+          <a:xfrm>
+            <a:off x="6629400" y="2423160"/>
+            <a:ext cx="4983480" cy="3246120"/>
+          </a:xfrm>
+          <a:prstGeom prst="rect">
+            <a:avLst/>
+          </a:prstGeom>
+          <a:solidFill>
+            <a:srgbClr val="F3F6F8"/>
+          </a:solidFill>
+          <a:ln w="9525">
+            <a:solidFill>
+              <a:srgbClr val="D7DEE8"/>
+            </a:solidFill>
+          </a:ln>
+        </p:spPr>
+        <p:txBody>
+          <a:bodyPr/>
+          <a:lstStyle/>
+          <a:p/>
+        </p:txBody>
+      </p:sp>
+      <p:sp>
+        <p:nvSpPr>
+          <p:cNvPr id="9" name="slide-number"/>
+          <p:cNvSpPr txBox="1"/>
+          <p:nvPr/>
+        </p:nvSpPr>
+        <p:spPr>
+          <a:xfrm>
+            <a:off x="11173968" y="6364224"/>
+            <a:ext cx="502920" cy="182880"/>
+          </a:xfrm>
+          <a:prstGeom prst="rect">
+            <a:avLst/>
+          </a:prstGeom>
+          <a:noFill/>
+          <a:ln>
+            <a:noFill/>
+          </a:ln>
+        </p:spPr>
+        <p:txBody>
+          <a:bodyPr wrap="square" anchor="t"/>
+          <a:lstStyle/>
+          <a:p>
+            <a:pPr algn="l"/>
+            <a:r>
+              <a:rPr lang="en-US" sz="900">
+                <a:solidFill>
+                  <a:srgbClr val="4B5563"/>
+                </a:solidFill>
+                <a:latin typeface="Arial"/>
+              </a:rPr>
+              <a:t>10</a:t>
+            </a:r>
+            <a:endParaRPr lang="en-US" sz="900"/>
+          </a:p>
+        </p:txBody>
+      </p:sp>
+      <p:sp>
+        <p:nvSpPr>
+          <p:cNvPr id="10" name="made-by"/>
+          <p:cNvSpPr txBox="1"/>
+          <p:nvPr/>
+        </p:nvSpPr>
+        <p:spPr>
+          <a:xfrm>
+            <a:off x="530352" y="6327648"/>
+            <a:ext cx="3840480" cy="228600"/>
+          </a:xfrm>
+          <a:prstGeom prst="rect">
+            <a:avLst/>
+          </a:prstGeom>
+          <a:noFill/>
+          <a:ln>
+            <a:noFill/>
+          </a:ln>
+        </p:spPr>
+        <p:txBody>
+          <a:bodyPr wrap="square" anchor="t"/>
+          <a:lstStyle/>
+          <a:p>
+            <a:pPr algn="l"/>
+            <a:r>
+              <a:rPr lang="en-US" sz="900">
+                <a:solidFill>
+                  <a:srgbClr val="4B5563"/>
+                </a:solidFill>
+                <a:latin typeface="Arial"/>
+              </a:rPr>
+              <a:t>Made by Mohammed Alkhandagji</a:t>
+            </a:r>
+            <a:endParaRPr lang="en-US" sz="900"/>
+          </a:p>
+        </p:txBody>
+      </p:sp>
+      <p:sp>
+        <p:nvSpPr>
+          <p:cNvPr id="11" name="card-11"/>
+          <p:cNvSpPr/>
+          <p:nvPr/>
+        </p:nvSpPr>
+        <p:spPr>
+          <a:xfrm>
+            <a:off x="6931152" y="2651760"/>
+            <a:ext cx="4370832" cy="804672"/>
+          </a:xfrm>
+          <a:prstGeom prst="rect">
+            <a:avLst/>
+          </a:prstGeom>
+          <a:solidFill>
+            <a:srgbClr val="FFFFFF"/>
+          </a:solidFill>
+          <a:ln w="9525">
+            <a:solidFill>
+              <a:srgbClr val="D7DEE8"/>
+            </a:solidFill>
+          </a:ln>
+        </p:spPr>
+        <p:txBody>
+          <a:bodyPr/>
+          <a:lstStyle/>
+          <a:p/>
+        </p:txBody>
+      </p:sp>
+      <p:sp>
+        <p:nvSpPr>
+          <p:cNvPr id="12" name="card-title-11"/>
+          <p:cNvSpPr txBox="1"/>
+          <p:nvPr/>
+        </p:nvSpPr>
+        <p:spPr>
+          <a:xfrm>
+            <a:off x="7114032" y="2779776"/>
+            <a:ext cx="3977639" cy="201168"/>
+          </a:xfrm>
+          <a:prstGeom prst="rect">
+            <a:avLst/>
+          </a:prstGeom>
+          <a:noFill/>
+          <a:ln>
+            <a:noFill/>
+          </a:ln>
+        </p:spPr>
+        <p:txBody>
+          <a:bodyPr wrap="square" anchor="t"/>
+          <a:lstStyle/>
+          <a:p>
+            <a:pPr algn="l"/>
+            <a:r>
+              <a:rPr lang="en-US" sz="1300" b="1">
+                <a:solidFill>
+                  <a:srgbClr val="00A651"/>
+                </a:solidFill>
+                <a:latin typeface="Arial"/>
+              </a:rPr>
+              <a:t>Outcome</a:t>
+            </a:r>
+            <a:endParaRPr lang="en-US" sz="1300"/>
+          </a:p>
+        </p:txBody>
+      </p:sp>
+      <p:sp>
+        <p:nvSpPr>
+          <p:cNvPr id="13" name="card-body-11"/>
+          <p:cNvSpPr txBox="1"/>
+          <p:nvPr/>
+        </p:nvSpPr>
+        <p:spPr>
+          <a:xfrm>
+            <a:off x="7114032" y="3035808"/>
+            <a:ext cx="3977639" cy="219456"/>
+          </a:xfrm>
+          <a:prstGeom prst="rect">
+            <a:avLst/>
+          </a:prstGeom>
+          <a:noFill/>
+          <a:ln>
+            <a:noFill/>
+          </a:ln>
+        </p:spPr>
+        <p:txBody>
+          <a:bodyPr wrap="square" anchor="t"/>
+          <a:lstStyle/>
+          <a:p>
+            <a:pPr algn="l"/>
+            <a:r>
+              <a:rPr lang="en-US" sz="1100">
+                <a:solidFill>
+                  <a:srgbClr val="4B5563"/>
+                </a:solidFill>
+                <a:latin typeface="Arial"/>
+              </a:rPr>
+              <a:t>Faster support</a:t>
+            </a:r>
+            <a:endParaRPr lang="en-US" sz="1100"/>
+          </a:p>
+        </p:txBody>
+      </p:sp>
+      <p:sp>
+        <p:nvSpPr>
+          <p:cNvPr id="14" name="card-14"/>
+          <p:cNvSpPr/>
+          <p:nvPr/>
+        </p:nvSpPr>
+        <p:spPr>
+          <a:xfrm>
+            <a:off x="6931152" y="3611880"/>
+            <a:ext cx="4370832" cy="804672"/>
+          </a:xfrm>
+          <a:prstGeom prst="rect">
+            <a:avLst/>
+          </a:prstGeom>
+          <a:solidFill>
+            <a:srgbClr val="FFFFFF"/>
+          </a:solidFill>
+          <a:ln w="9525">
+            <a:solidFill>
+              <a:srgbClr val="D7DEE8"/>
+            </a:solidFill>
+          </a:ln>
+        </p:spPr>
+        <p:txBody>
+          <a:bodyPr/>
+          <a:lstStyle/>
+          <a:p/>
+        </p:txBody>
+      </p:sp>
+      <p:sp>
+        <p:nvSpPr>
+          <p:cNvPr id="15" name="card-title-14"/>
+          <p:cNvSpPr txBox="1"/>
+          <p:nvPr/>
+        </p:nvSpPr>
+        <p:spPr>
+          <a:xfrm>
+            <a:off x="7114032" y="3739896"/>
+            <a:ext cx="3977639" cy="201168"/>
+          </a:xfrm>
+          <a:prstGeom prst="rect">
+            <a:avLst/>
+          </a:prstGeom>
+          <a:noFill/>
+          <a:ln>
+            <a:noFill/>
+          </a:ln>
+        </p:spPr>
+        <p:txBody>
+          <a:bodyPr wrap="square" anchor="t"/>
+          <a:lstStyle/>
+          <a:p>
+            <a:pPr algn="l"/>
+            <a:r>
+              <a:rPr lang="en-US" sz="1300" b="1">
+                <a:solidFill>
+                  <a:srgbClr val="00A651"/>
+                </a:solidFill>
+                <a:latin typeface="Arial"/>
+              </a:rPr>
+              <a:t>Control</a:t>
+            </a:r>
+            <a:endParaRPr lang="en-US" sz="1300"/>
+          </a:p>
+        </p:txBody>
+      </p:sp>
+      <p:sp>
+        <p:nvSpPr>
+          <p:cNvPr id="16" name="card-body-14"/>
+          <p:cNvSpPr txBox="1"/>
+          <p:nvPr/>
+        </p:nvSpPr>
+        <p:spPr>
+          <a:xfrm>
+            <a:off x="7114032" y="3995928"/>
+            <a:ext cx="3977639" cy="219456"/>
+          </a:xfrm>
+          <a:prstGeom prst="rect">
+            <a:avLst/>
+          </a:prstGeom>
+          <a:noFill/>
+          <a:ln>
+            <a:noFill/>
+          </a:ln>
+        </p:spPr>
+        <p:txBody>
+          <a:bodyPr wrap="square" anchor="t"/>
+          <a:lstStyle/>
+          <a:p>
+            <a:pPr algn="l"/>
+            <a:r>
+              <a:rPr lang="en-US" sz="1100">
+                <a:solidFill>
+                  <a:srgbClr val="4B5563"/>
+                </a:solidFill>
+                <a:latin typeface="Arial"/>
+              </a:rPr>
+              <a:t>Cleaner content</a:t>
+            </a:r>
+            <a:endParaRPr lang="en-US" sz="1100"/>
+          </a:p>
+        </p:txBody>
+      </p:sp>
+      <p:sp>
+        <p:nvSpPr>
+          <p:cNvPr id="17" name="card-17"/>
+          <p:cNvSpPr/>
+          <p:nvPr/>
+        </p:nvSpPr>
+        <p:spPr>
+          <a:xfrm>
+            <a:off x="6931152" y="4572000"/>
+            <a:ext cx="4370832" cy="804672"/>
+          </a:xfrm>
+          <a:prstGeom prst="rect">
+            <a:avLst/>
+          </a:prstGeom>
+          <a:solidFill>
+            <a:srgbClr val="FFFFFF"/>
+          </a:solidFill>
+          <a:ln w="9525">
+            <a:solidFill>
+              <a:srgbClr val="D7DEE8"/>
+            </a:solidFill>
+          </a:ln>
+        </p:spPr>
+        <p:txBody>
+          <a:bodyPr/>
+          <a:lstStyle/>
+          <a:p/>
+        </p:txBody>
+      </p:sp>
+      <p:sp>
+        <p:nvSpPr>
+          <p:cNvPr id="18" name="card-title-17"/>
+          <p:cNvSpPr txBox="1"/>
+          <p:nvPr/>
+        </p:nvSpPr>
+        <p:spPr>
+          <a:xfrm>
+            <a:off x="7114032" y="4700016"/>
+            <a:ext cx="3977639" cy="201168"/>
+          </a:xfrm>
+          <a:prstGeom prst="rect">
+            <a:avLst/>
+          </a:prstGeom>
+          <a:noFill/>
+          <a:ln>
+            <a:noFill/>
+          </a:ln>
+        </p:spPr>
+        <p:txBody>
+          <a:bodyPr wrap="square" anchor="t"/>
+          <a:lstStyle/>
+          <a:p>
+            <a:pPr algn="l"/>
+            <a:r>
+              <a:rPr lang="en-US" sz="1300" b="1">
+                <a:solidFill>
+                  <a:srgbClr val="00A651"/>
+                </a:solidFill>
+                <a:latin typeface="Arial"/>
+              </a:rPr>
+              <a:t>Cost</a:t>
+            </a:r>
+            <a:endParaRPr lang="en-US" sz="1300"/>
+          </a:p>
+        </p:txBody>
+      </p:sp>
+      <p:sp>
+        <p:nvSpPr>
+          <p:cNvPr id="19" name="card-body-17"/>
+          <p:cNvSpPr txBox="1"/>
+          <p:nvPr/>
+        </p:nvSpPr>
+        <p:spPr>
+          <a:xfrm>
+            <a:off x="7114032" y="4956048"/>
+            <a:ext cx="3977639" cy="219456"/>
+          </a:xfrm>
+          <a:prstGeom prst="rect">
+            <a:avLst/>
+          </a:prstGeom>
+          <a:noFill/>
+          <a:ln>
+            <a:noFill/>
+          </a:ln>
+        </p:spPr>
+        <p:txBody>
+          <a:bodyPr wrap="square" anchor="t"/>
+          <a:lstStyle/>
+          <a:p>
+            <a:pPr algn="l"/>
+            <a:r>
+              <a:rPr lang="en-US" sz="1100">
+                <a:solidFill>
+                  <a:srgbClr val="4B5563"/>
+                </a:solidFill>
+                <a:latin typeface="Arial"/>
+              </a:rPr>
+              <a:t>Predictable baseline</a:t>
+            </a:r>
+            <a:endParaRPr lang="en-US" sz="1100"/>
           </a:p>
         </p:txBody>
       </p:sp>

</xml_diff>